<commit_message>
fix(cartazes): install approved Office-compatible poster templates
</commit_message>
<xml_diff>
--- a/src/srstudio/assets/poster_templates/legacy/models/CARTAZ_VENDA.pptx
+++ b/src/srstudio/assets/poster_templates/legacy/models/CARTAZ_VENDA.pptx
@@ -3407,7 +3407,7 @@
 </file>
 
 <file path=ppt/slides/slide1.xml><?xml version="1.0" encoding="utf-8"?>
-<p:sld xmlns:a="http://schemas.openxmlformats.org/drawingml/2006/main" xmlns:r="http://schemas.openxmlformats.org/officeDocument/2006/relationships" xmlns:p="http://schemas.openxmlformats.org/presentationml/2006/main">
+<p:sld xmlns:a="http://schemas.openxmlformats.org/drawingml/2006/main" xmlns:r="http://schemas.openxmlformats.org/officeDocument/2006/relationships" xmlns:p="http://schemas.openxmlformats.org/presentationml/2006/main" showMasterSp="1">
   <p:cSld>
     <p:spTree>
       <p:nvGrpSpPr>
@@ -3439,8 +3439,8 @@
         </p:nvSpPr>
         <p:spPr>
           <a:xfrm>
-            <a:off x="0" y="2217663"/>
-            <a:ext cx="6858000" cy="2888079"/>
+            <a:off x="698500" y="2584450"/>
+            <a:ext cx="5657850" cy="1790700"/>
           </a:xfrm>
           <a:prstGeom prst="rect">
             <a:avLst/>
@@ -3448,36 +3448,38 @@
           <a:noFill/>
         </p:spPr>
         <p:txBody>
-          <a:bodyPr wrap="none" rtlCol="0">
-            <a:noAutofit/>
+          <a:bodyPr wrap="none" fromWordArt="1" lIns="0" rIns="0" tIns="0" bIns="0">
+            <a:prstTxWarp prst="textPlain">
+              <a:avLst/>
+            </a:prstTxWarp>
           </a:bodyPr>
           <a:lstStyle/>
           <a:p>
             <a:pPr algn="ctr"/>
             <a:r>
-              <a:rPr lang="pt-BR" sz="6600" dirty="0">
+              <a:rPr lang="pt-BR" sz="7200" dirty="0">
                 <a:latin typeface="Algerian" panose="04020705040A02060702" pitchFamily="82" charset="0"/>
               </a:rPr>
-              <a:t>CESTA BASICA</a:t>
+              <a:t>bolacha </a:t>
             </a:r>
           </a:p>
           <a:p>
             <a:pPr algn="ctr"/>
             <a:r>
-              <a:rPr lang="pt-BR" sz="6600" dirty="0">
+              <a:rPr lang="pt-BR" sz="7200" dirty="0">
                 <a:latin typeface="Algerian" panose="04020705040A02060702" pitchFamily="82" charset="0"/>
               </a:rPr>
-              <a:t>VASCONCELOS</a:t>
-            </a:r>
-          </a:p>
-          <a:p>
-            <a:pPr algn="ctr"/>
-            <a:r>
-              <a:rPr lang="pt-BR" sz="6600" dirty="0">
+              <a:t>Araruta </a:t>
+            </a:r>
+            <a:r>
+              <a:rPr lang="pt-BR" sz="7200" dirty="0" err="1">
                 <a:latin typeface="Algerian" panose="04020705040A02060702" pitchFamily="82" charset="0"/>
               </a:rPr>
-              <a:t>DIAMANTE</a:t>
-            </a:r>
+              <a:t>sr</a:t>
+            </a:r>
+            <a:endParaRPr lang="pt-BR" sz="7200" dirty="0">
+              <a:latin typeface="Algerian" panose="04020705040A02060702" pitchFamily="82" charset="0"/>
+            </a:endParaRPr>
           </a:p>
         </p:txBody>
       </p:sp>
@@ -3643,14 +3645,11 @@
           <a:p>
             <a:pPr algn="ctr"/>
             <a:r>
-              <a:rPr lang="pt-BR" sz="13800">
+              <a:rPr lang="pt-BR" sz="13800" dirty="0">
                 <a:latin typeface="Algerian" panose="04020705040A02060702" pitchFamily="82" charset="0"/>
               </a:rPr>
-              <a:t>196,78</a:t>
-            </a:r>
-            <a:endParaRPr lang="pt-BR" sz="13800" dirty="0">
-              <a:latin typeface="Algerian" panose="04020705040A02060702" pitchFamily="82" charset="0"/>
-            </a:endParaRPr>
+              <a:t>14,89</a:t>
+            </a:r>
           </a:p>
         </p:txBody>
       </p:sp>

</xml_diff>